<commit_message>
fix: regenerate PPT with corrected judge metric labels
- "+26pp" now labeled as heuristic judge comparison (D 48% vs C 22%)
- External Claude Sonnet 4.6 result (0.912 / 92%) added alongside

Co-Authored-By: Claude Sonnet 4.6 <noreply@anthropic.com>
</commit_message>
<xml_diff>
--- a/RAGixAI_Presentation.pptx
+++ b/RAGixAI_Presentation.pptx
@@ -38111,7 +38111,7 @@
                   <a:srgbClr val="CCCCCC"/>
                 </a:solidFill>
               </a:rPr>
-              <a:t>Only config meeting all 5 thresholds. Reranker: +0.11 correctness, +26pp judge pass, -27s latency.</a:t>
+              <a:t>Only config meeting all 5 thresholds. Reranker: +0.11 correctness, +26pp heuristic judge pass (D 48% vs C 22%), -27s latency. External Claude Sonnet judge: 0.912 / 92%.</a:t>
             </a:r>
           </a:p>
         </p:txBody>
@@ -40157,7 +40157,7 @@
                   <a:srgbClr val="CCCCCC"/>
                 </a:solidFill>
               </a:rPr>
-              <a:t>• Cross-encoder reranking is highest-ROI single improvement: +0.11 correctness, -27s latency, +26pp judge</a:t>
+              <a:t>• Cross-encoder reranking is highest-ROI single improvement: +0.11 correctness, -27s latency, +26pp heuristic judge pass (D 48% vs C 22%)</a:t>
             </a:r>
           </a:p>
         </p:txBody>

</xml_diff>